<commit_message>
Evidence-backed real-patient model, real alert evaluation, CI
- src/eval/real_model.py: CGM-only LightGBM trained on 100 real ShanghaiT2DM
  patients; alert policy evaluated episode by episode on real patients with
  thresholds set on held-out training patients per fold. Real lows: 35% warned
  >= 30 min ahead (53% at 15 min), 0.61 alerts/day, 44% PPV, median lead 25 min
  (synthetic-trained zero-shot: 29%, PPV 31%). Saved model + thresholds ship in
  the demo bundle (tree splits only, no patient data).
- Twin context can switch models without reloading data (with_model); the
  dashboard has a Risk model selector with the real-patient evidence shown.
- GitHub Actions: full suite on the pinned stack (CPU torch) and the dashboard
  on the Streamlit Cloud dependency set from the demo bundle.
- README, model card, deployment path, deck and video script now pair the
  synthetic alert figure with the real-patient one. 131 tests.

Co-Authored-By: Claude Opus 5.5 <noreply@anthropic.com>
</commit_message>
<xml_diff>
--- a/docs/presentation.pptx
+++ b/docs/presentation.pptx
@@ -126,25 +126,25 @@
   <p:extLst>
     <p:ext uri="{521415D9-36F7-43E2-AB2F-B90AF26B5E84}">
       <p14:sectionLst xmlns:p14="http://schemas.microsoft.com/office/powerpoint/2010/main">
-        <p14:section name="Opening" id="{57b1bb96-f43a-72dc-b5af-5664567b2588}">
+        <p14:section name="Opening" id="{6e78eef3-7965-1797-cd92-0d324b35926c}">
           <p14:sldIdLst>
             <p14:sldId id="256"/>
           </p14:sldIdLst>
         </p14:section>
-        <p14:section name="Problem" id="{5d36fc29-639a-d0db-507c-3758fcc0114e}">
+        <p14:section name="Problem" id="{3d2926d5-d738-5ac7-f61f-79be4f307c6a}">
           <p14:sldIdLst>
             <p14:sldId id="257"/>
             <p14:sldId id="258"/>
           </p14:sldIdLst>
         </p14:section>
-        <p14:section name="How it works" id="{2f45d542-b858-9a41-396d-4c0e4cae0372}">
+        <p14:section name="How it works" id="{b99dd602-912f-11be-31b2-ebdf759bd807}">
           <p14:sldIdLst>
             <p14:sldId id="259"/>
             <p14:sldId id="260"/>
             <p14:sldId id="261"/>
           </p14:sldIdLst>
         </p14:section>
-        <p14:section name="Results" id="{6b0d1bba-593a-c99a-6222-50a6f98c7e2d}">
+        <p14:section name="Results" id="{c7234be5-2f5e-177d-76c5-036e3ccad3fe}">
           <p14:sldIdLst>
             <p14:sldId id="262"/>
             <p14:sldId id="263"/>
@@ -153,7 +153,7 @@
             <p14:sldId id="266"/>
           </p14:sldIdLst>
         </p14:section>
-        <p14:section name="Real data" id="{08b7ea3e-3e83-2440-d185-1ebece5a16d7}">
+        <p14:section name="Real data" id="{1a63fb3d-1dab-3262-083e-889663aa15c5}">
           <p14:sldIdLst>
             <p14:sldId id="267"/>
             <p14:sldId id="268"/>
@@ -162,7 +162,7 @@
             <p14:sldId id="271"/>
           </p14:sldIdLst>
         </p14:section>
-        <p14:section name="Path forward" id="{700f3495-07a8-3eb8-fd08-417d47d9c7c0}">
+        <p14:section name="Path forward" id="{d3db9143-6ce3-c092-bacd-2c33bff0ae08}">
           <p14:sldIdLst>
             <p14:sldId id="272"/>
             <p14:sldId id="273"/>
@@ -3930,7 +3930,7 @@
           <a:p>
             <a:r>
               <a:rPr lang="en-US" dirty="0"/>
-              <a:t>Accuracy is not enough; alarm fatigue kills alerting systems. One alert per episode, a 90-minute refractory period, thresholds chosen on validation patients. Result on test patients: 76% of lows warned 30 minutes ahead, median 65 minutes, about one alert every two days, two out of three alerts real. Synthetic data, so real numbers will be lower.</a:t>
+              <a:t>Accuracy is not enough; alarm fatigue kills alerting systems. One alert per episode, a 90-minute refractory period, never while the CGM already reads low, thresholds chosen on validation patients. Synthetic test patients: 76% of lows warned 30 minutes ahead at about one alert every two days. Then the honest part: the same policy on 100 real patients, with a model trained on real data, warns of 35% of lows 30 minutes ahead (53% at 15 minutes) at 0.6 alerts a day. Real lows arrive faster than simulated ones; the synthetic figure is an upper bound.</a:t>
             </a:r>
             <a:endParaRPr lang="en-US" dirty="0"/>
           </a:p>
@@ -6999,7 +6999,7 @@
                   <a:schemeClr val="tx1"/>
                 </a:solidFill>
               </a:rPr>
-              <a:t>Alerting can be tuned to about one alert every two days</a:t>
+              <a:t>On real patients, alerts warn of 35% of lows 30 min ahead at 0.6 a day: an honest baseline to improve</a:t>
             </a:r>
             <a:endParaRPr lang="en-US" sz="1600" dirty="0"/>
           </a:p>
@@ -7036,6 +7036,24 @@
                 </a:solidFill>
               </a:rPr>
               <a:t>A personalised twin halves projection error, with honest bands</a:t>
+            </a:r>
+            <a:endParaRPr lang="en-US" sz="1600" dirty="0"/>
+          </a:p>
+          <a:p>
+            <a:pPr marL="342900" indent="-342900">
+              <a:spcAft>
+                <a:spcPts val="1000"/>
+              </a:spcAft>
+              <a:buSzPct val="100000"/>
+              <a:buChar char="•"/>
+            </a:pPr>
+            <a:r>
+              <a:rPr lang="en-US" sz="1600" dirty="0">
+                <a:solidFill>
+                  <a:schemeClr val="tx1"/>
+                </a:solidFill>
+              </a:rPr>
+              <a:t>The product ships a model trained on real patients</a:t>
             </a:r>
             <a:endParaRPr lang="en-US" sz="1600" dirty="0"/>
           </a:p>
@@ -8265,7 +8283,7 @@
                 <a:ea typeface="Cambria" pitchFamily="34" charset="-122"/>
                 <a:cs typeface="Cambria" pitchFamily="34" charset="-120"/>
               </a:rPr>
-              <a:t>128</a:t>
+              <a:t>131</a:t>
             </a:r>
             <a:endParaRPr lang="en-US" sz="4600" dirty="0"/>
           </a:p>
@@ -8301,7 +8319,7 @@
                   <a:schemeClr val="tx1"/>
                 </a:solidFill>
               </a:rPr>
-              <a:t>automated tests</a:t>
+              <a:t>automated tests, run by CI on every push</a:t>
             </a:r>
             <a:endParaRPr lang="en-US" sz="1400" dirty="0"/>
           </a:p>
@@ -11834,7 +11852,7 @@
                   <a:schemeClr val="tx1"/>
                 </a:solidFill>
               </a:rPr>
-              <a:t>Fixed seeds, one command rebuilds everything, 128 automated tests</a:t>
+              <a:t>Fixed seeds, one command rebuilds everything, 131 tests run on every push</a:t>
             </a:r>
             <a:endParaRPr lang="en-US" sz="1500" dirty="0"/>
           </a:p>
@@ -12239,7 +12257,7 @@
                 <a:ea typeface="Cambria" pitchFamily="34" charset="-122"/>
                 <a:cs typeface="Cambria" pitchFamily="34" charset="-120"/>
               </a:rPr>
-              <a:t>Alerts a clinic can live with</a:t>
+              <a:t>Alerts a clinic can live with, tested on real patients too</a:t>
             </a:r>
             <a:endParaRPr lang="en-US" sz="3200" dirty="0"/>
           </a:p>
@@ -12247,18 +12265,54 @@
       </p:sp>
       <p:sp>
         <p:nvSpPr>
-          <p:cNvPr id="3" name="card"/>
+          <p:cNvPr id="3" name="Text 1"/>
+          <p:cNvSpPr txBox="1"/>
+          <p:nvPr/>
+        </p:nvSpPr>
+        <p:spPr>
+          <a:xfrm>
+            <a:off x="548640" y="1234440"/>
+            <a:ext cx="11064240" cy="320040"/>
+          </a:xfrm>
+          <a:prstGeom prst="rect">
+            <a:avLst/>
+          </a:prstGeom>
+          <a:noFill/>
+          <a:ln/>
+        </p:spPr>
+        <p:txBody>
+          <a:bodyPr wrap="square" lIns="0" tIns="0" rIns="0" bIns="0" rtlCol="0" anchor="t"/>
+          <a:lstStyle/>
+          <a:p>
+            <a:pPr indent="0" marL="0">
+              <a:buNone/>
+            </a:pPr>
+            <a:r>
+              <a:rPr lang="en-US" sz="1500" b="1" dirty="0">
+                <a:solidFill>
+                  <a:schemeClr val="tx2"/>
+                </a:solidFill>
+              </a:rPr>
+              <a:t>Synthetic test patients (60), synthetic-trained model</a:t>
+            </a:r>
+            <a:endParaRPr lang="en-US" sz="1500" dirty="0"/>
+          </a:p>
+        </p:txBody>
+      </p:sp>
+      <p:sp>
+        <p:nvSpPr>
+          <p:cNvPr id="4" name="card"/>
           <p:cNvSpPr/>
           <p:nvPr/>
         </p:nvSpPr>
         <p:spPr>
           <a:xfrm>
-            <a:off x="548640" y="1371600"/>
-            <a:ext cx="2606040" cy="2514600"/>
+            <a:off x="548640" y="1645920"/>
+            <a:ext cx="2606040" cy="1874520"/>
           </a:xfrm>
           <a:prstGeom prst="roundRect">
             <a:avLst>
-              <a:gd name="adj" fmla="val 4364"/>
+              <a:gd name="adj" fmla="val 5854"/>
             </a:avLst>
           </a:prstGeom>
           <a:solidFill>
@@ -12269,14 +12323,14 @@
       </p:sp>
       <p:sp>
         <p:nvSpPr>
-          <p:cNvPr id="4" name="Text 2"/>
+          <p:cNvPr id="5" name="Text 3"/>
           <p:cNvSpPr txBox="1"/>
           <p:nvPr/>
         </p:nvSpPr>
         <p:spPr>
           <a:xfrm>
-            <a:off x="822960" y="1463040"/>
-            <a:ext cx="2148840" cy="868680"/>
+            <a:off x="822960" y="1737360"/>
+            <a:ext cx="2148840" cy="777240"/>
           </a:xfrm>
           <a:prstGeom prst="rect">
             <a:avLst/>
@@ -12292,9 +12346,9 @@
               <a:buNone/>
             </a:pPr>
             <a:r>
-              <a:rPr lang="en-US" sz="4600" b="1" dirty="0">
-                <a:solidFill>
-                  <a:schemeClr val="accent3"/>
+              <a:rPr lang="en-US" sz="4000" b="1" dirty="0">
+                <a:solidFill>
+                  <a:schemeClr val="accent1"/>
                 </a:solidFill>
                 <a:latin typeface="Cambria" pitchFamily="34" charset="0"/>
                 <a:ea typeface="Cambria" pitchFamily="34" charset="-122"/>
@@ -12302,19 +12356,19 @@
               </a:rPr>
               <a:t>76%</a:t>
             </a:r>
-            <a:endParaRPr lang="en-US" sz="4600" dirty="0"/>
-          </a:p>
-        </p:txBody>
-      </p:sp>
-      <p:sp>
-        <p:nvSpPr>
-          <p:cNvPr id="5" name="Text 3"/>
+            <a:endParaRPr lang="en-US" sz="4000" dirty="0"/>
+          </a:p>
+        </p:txBody>
+      </p:sp>
+      <p:sp>
+        <p:nvSpPr>
+          <p:cNvPr id="6" name="Text 4"/>
           <p:cNvSpPr txBox="1"/>
           <p:nvPr/>
         </p:nvSpPr>
         <p:spPr>
           <a:xfrm>
-            <a:off x="822960" y="2377440"/>
+            <a:off x="822960" y="2606040"/>
             <a:ext cx="2148840" cy="822960"/>
           </a:xfrm>
           <a:prstGeom prst="rect">
@@ -12336,7 +12390,7 @@
                   <a:schemeClr val="tx1"/>
                 </a:solidFill>
               </a:rPr>
-              <a:t>of low-glucose episodes warned at least 30 minutes ahead</a:t>
+              <a:t>of lows warned at least 30 min ahead</a:t>
             </a:r>
             <a:endParaRPr lang="en-US" sz="1400" dirty="0"/>
           </a:p>
@@ -12344,18 +12398,18 @@
       </p:sp>
       <p:sp>
         <p:nvSpPr>
-          <p:cNvPr id="6" name="card"/>
+          <p:cNvPr id="7" name="card"/>
           <p:cNvSpPr/>
           <p:nvPr/>
         </p:nvSpPr>
         <p:spPr>
           <a:xfrm>
-            <a:off x="3364992" y="1371600"/>
-            <a:ext cx="2606040" cy="2514600"/>
+            <a:off x="3364992" y="1645920"/>
+            <a:ext cx="2606040" cy="1874520"/>
           </a:xfrm>
           <a:prstGeom prst="roundRect">
             <a:avLst>
-              <a:gd name="adj" fmla="val 4364"/>
+              <a:gd name="adj" fmla="val 5854"/>
             </a:avLst>
           </a:prstGeom>
           <a:solidFill>
@@ -12366,14 +12420,14 @@
       </p:sp>
       <p:sp>
         <p:nvSpPr>
-          <p:cNvPr id="7" name="Text 5"/>
+          <p:cNvPr id="8" name="Text 6"/>
           <p:cNvSpPr txBox="1"/>
           <p:nvPr/>
         </p:nvSpPr>
         <p:spPr>
           <a:xfrm>
-            <a:off x="3639312" y="1463040"/>
-            <a:ext cx="2148840" cy="868680"/>
+            <a:off x="3639312" y="1737360"/>
+            <a:ext cx="2148840" cy="777240"/>
           </a:xfrm>
           <a:prstGeom prst="rect">
             <a:avLst/>
@@ -12389,9 +12443,9 @@
               <a:buNone/>
             </a:pPr>
             <a:r>
-              <a:rPr lang="en-US" sz="4600" b="1" dirty="0">
-                <a:solidFill>
-                  <a:schemeClr val="accent3"/>
+              <a:rPr lang="en-US" sz="4000" b="1" dirty="0">
+                <a:solidFill>
+                  <a:schemeClr val="accent1"/>
                 </a:solidFill>
                 <a:latin typeface="Cambria" pitchFamily="34" charset="0"/>
                 <a:ea typeface="Cambria" pitchFamily="34" charset="-122"/>
@@ -12399,19 +12453,19 @@
               </a:rPr>
               <a:t>65 min</a:t>
             </a:r>
-            <a:endParaRPr lang="en-US" sz="4600" dirty="0"/>
-          </a:p>
-        </p:txBody>
-      </p:sp>
-      <p:sp>
-        <p:nvSpPr>
-          <p:cNvPr id="8" name="Text 6"/>
+            <a:endParaRPr lang="en-US" sz="4000" dirty="0"/>
+          </a:p>
+        </p:txBody>
+      </p:sp>
+      <p:sp>
+        <p:nvSpPr>
+          <p:cNvPr id="9" name="Text 7"/>
           <p:cNvSpPr txBox="1"/>
           <p:nvPr/>
         </p:nvSpPr>
         <p:spPr>
           <a:xfrm>
-            <a:off x="3639312" y="2377440"/>
+            <a:off x="3639312" y="2606040"/>
             <a:ext cx="2148840" cy="822960"/>
           </a:xfrm>
           <a:prstGeom prst="rect">
@@ -12433,7 +12487,7 @@
                   <a:schemeClr val="tx1"/>
                 </a:solidFill>
               </a:rPr>
-              <a:t>median warning time before a low begins</a:t>
+              <a:t>median warning</a:t>
             </a:r>
             <a:endParaRPr lang="en-US" sz="1400" dirty="0"/>
           </a:p>
@@ -12441,18 +12495,18 @@
       </p:sp>
       <p:sp>
         <p:nvSpPr>
-          <p:cNvPr id="9" name="card"/>
+          <p:cNvPr id="10" name="card"/>
           <p:cNvSpPr/>
           <p:nvPr/>
         </p:nvSpPr>
         <p:spPr>
           <a:xfrm>
-            <a:off x="6181344" y="1371600"/>
-            <a:ext cx="2606040" cy="2514600"/>
+            <a:off x="6181344" y="1645920"/>
+            <a:ext cx="2606040" cy="1874520"/>
           </a:xfrm>
           <a:prstGeom prst="roundRect">
             <a:avLst>
-              <a:gd name="adj" fmla="val 4364"/>
+              <a:gd name="adj" fmla="val 5854"/>
             </a:avLst>
           </a:prstGeom>
           <a:solidFill>
@@ -12463,14 +12517,14 @@
       </p:sp>
       <p:sp>
         <p:nvSpPr>
-          <p:cNvPr id="10" name="Text 8"/>
+          <p:cNvPr id="11" name="Text 9"/>
           <p:cNvSpPr txBox="1"/>
           <p:nvPr/>
         </p:nvSpPr>
         <p:spPr>
           <a:xfrm>
-            <a:off x="6455664" y="1463040"/>
-            <a:ext cx="2148840" cy="868680"/>
+            <a:off x="6455664" y="1737360"/>
+            <a:ext cx="2148840" cy="777240"/>
           </a:xfrm>
           <a:prstGeom prst="rect">
             <a:avLst/>
@@ -12486,7 +12540,7 @@
               <a:buNone/>
             </a:pPr>
             <a:r>
-              <a:rPr lang="en-US" sz="4600" b="1" dirty="0">
+              <a:rPr lang="en-US" sz="4000" b="1" dirty="0">
                 <a:solidFill>
                   <a:schemeClr val="accent1"/>
                 </a:solidFill>
@@ -12496,19 +12550,19 @@
               </a:rPr>
               <a:t>0.49</a:t>
             </a:r>
-            <a:endParaRPr lang="en-US" sz="4600" dirty="0"/>
-          </a:p>
-        </p:txBody>
-      </p:sp>
-      <p:sp>
-        <p:nvSpPr>
-          <p:cNvPr id="11" name="Text 9"/>
+            <a:endParaRPr lang="en-US" sz="4000" dirty="0"/>
+          </a:p>
+        </p:txBody>
+      </p:sp>
+      <p:sp>
+        <p:nvSpPr>
+          <p:cNvPr id="12" name="Text 10"/>
           <p:cNvSpPr txBox="1"/>
           <p:nvPr/>
         </p:nvSpPr>
         <p:spPr>
           <a:xfrm>
-            <a:off x="6455664" y="2377440"/>
+            <a:off x="6455664" y="2606040"/>
             <a:ext cx="2148840" cy="822960"/>
           </a:xfrm>
           <a:prstGeom prst="rect">
@@ -12530,7 +12584,7 @@
                   <a:schemeClr val="tx1"/>
                 </a:solidFill>
               </a:rPr>
-              <a:t>low-glucose alerts per patient per day (about one every two days)</a:t>
+              <a:t>alerts per patient-day</a:t>
             </a:r>
             <a:endParaRPr lang="en-US" sz="1400" dirty="0"/>
           </a:p>
@@ -12538,18 +12592,18 @@
       </p:sp>
       <p:sp>
         <p:nvSpPr>
-          <p:cNvPr id="12" name="card"/>
+          <p:cNvPr id="13" name="card"/>
           <p:cNvSpPr/>
           <p:nvPr/>
         </p:nvSpPr>
         <p:spPr>
           <a:xfrm>
-            <a:off x="8997696" y="1371600"/>
-            <a:ext cx="2606040" cy="2514600"/>
+            <a:off x="8997696" y="1645920"/>
+            <a:ext cx="2606040" cy="1874520"/>
           </a:xfrm>
           <a:prstGeom prst="roundRect">
             <a:avLst>
-              <a:gd name="adj" fmla="val 4364"/>
+              <a:gd name="adj" fmla="val 5854"/>
             </a:avLst>
           </a:prstGeom>
           <a:solidFill>
@@ -12560,14 +12614,14 @@
       </p:sp>
       <p:sp>
         <p:nvSpPr>
-          <p:cNvPr id="13" name="Text 11"/>
+          <p:cNvPr id="14" name="Text 12"/>
           <p:cNvSpPr txBox="1"/>
           <p:nvPr/>
         </p:nvSpPr>
         <p:spPr>
           <a:xfrm>
-            <a:off x="9272016" y="1463040"/>
-            <a:ext cx="2148840" cy="868680"/>
+            <a:off x="9272016" y="1737360"/>
+            <a:ext cx="2148840" cy="777240"/>
           </a:xfrm>
           <a:prstGeom prst="rect">
             <a:avLst/>
@@ -12583,7 +12637,7 @@
               <a:buNone/>
             </a:pPr>
             <a:r>
-              <a:rPr lang="en-US" sz="4600" b="1" dirty="0">
+              <a:rPr lang="en-US" sz="4000" b="1" dirty="0">
                 <a:solidFill>
                   <a:schemeClr val="accent1"/>
                 </a:solidFill>
@@ -12593,19 +12647,19 @@
               </a:rPr>
               <a:t>66%</a:t>
             </a:r>
-            <a:endParaRPr lang="en-US" sz="4600" dirty="0"/>
-          </a:p>
-        </p:txBody>
-      </p:sp>
-      <p:sp>
-        <p:nvSpPr>
-          <p:cNvPr id="14" name="Text 12"/>
+            <a:endParaRPr lang="en-US" sz="4000" dirty="0"/>
+          </a:p>
+        </p:txBody>
+      </p:sp>
+      <p:sp>
+        <p:nvSpPr>
+          <p:cNvPr id="15" name="Text 13"/>
           <p:cNvSpPr txBox="1"/>
           <p:nvPr/>
         </p:nvSpPr>
         <p:spPr>
           <a:xfrm>
-            <a:off x="9272016" y="2377440"/>
+            <a:off x="9272016" y="2606040"/>
             <a:ext cx="2148840" cy="822960"/>
           </a:xfrm>
           <a:prstGeom prst="rect">
@@ -12627,7 +12681,7 @@
                   <a:schemeClr val="tx1"/>
                 </a:solidFill>
               </a:rPr>
-              <a:t>of low-glucose alerts are followed by a real low</a:t>
+              <a:t>of alerts followed by a real low</a:t>
             </a:r>
             <a:endParaRPr lang="en-US" sz="1400" dirty="0"/>
           </a:p>
@@ -12635,18 +12689,54 @@
       </p:sp>
       <p:sp>
         <p:nvSpPr>
-          <p:cNvPr id="15" name="card"/>
+          <p:cNvPr id="16" name="Text 14"/>
+          <p:cNvSpPr txBox="1"/>
+          <p:nvPr/>
+        </p:nvSpPr>
+        <p:spPr>
+          <a:xfrm>
+            <a:off x="548640" y="3749040"/>
+            <a:ext cx="11064240" cy="320040"/>
+          </a:xfrm>
+          <a:prstGeom prst="rect">
+            <a:avLst/>
+          </a:prstGeom>
+          <a:noFill/>
+          <a:ln/>
+        </p:spPr>
+        <p:txBody>
+          <a:bodyPr wrap="square" lIns="0" tIns="0" rIns="0" bIns="0" rtlCol="0" anchor="t"/>
+          <a:lstStyle/>
+          <a:p>
+            <a:pPr indent="0" marL="0">
+              <a:buNone/>
+            </a:pPr>
+            <a:r>
+              <a:rPr lang="en-US" sz="1500" b="1" dirty="0">
+                <a:solidFill>
+                  <a:schemeClr val="tx2"/>
+                </a:solidFill>
+              </a:rPr>
+              <a:t>Real patients (100, ShanghaiT2DM), real-trained model, thresholds set on other patients</a:t>
+            </a:r>
+            <a:endParaRPr lang="en-US" sz="1500" dirty="0"/>
+          </a:p>
+        </p:txBody>
+      </p:sp>
+      <p:sp>
+        <p:nvSpPr>
+          <p:cNvPr id="17" name="card"/>
           <p:cNvSpPr/>
           <p:nvPr/>
         </p:nvSpPr>
         <p:spPr>
           <a:xfrm>
-            <a:off x="548640" y="4206240"/>
-            <a:ext cx="11091672" cy="1508760"/>
+            <a:off x="548640" y="4160520"/>
+            <a:ext cx="2606040" cy="1874520"/>
           </a:xfrm>
           <a:prstGeom prst="roundRect">
             <a:avLst>
-              <a:gd name="adj" fmla="val 7273"/>
+              <a:gd name="adj" fmla="val 5854"/>
             </a:avLst>
           </a:prstGeom>
           <a:solidFill>
@@ -12657,14 +12747,53 @@
       </p:sp>
       <p:sp>
         <p:nvSpPr>
-          <p:cNvPr id="16" name="Text 14"/>
+          <p:cNvPr id="18" name="Text 16"/>
           <p:cNvSpPr txBox="1"/>
           <p:nvPr/>
         </p:nvSpPr>
         <p:spPr>
           <a:xfrm>
-            <a:off x="868680" y="4389120"/>
-            <a:ext cx="10424160" cy="1188720"/>
+            <a:off x="822960" y="4251960"/>
+            <a:ext cx="2148840" cy="777240"/>
+          </a:xfrm>
+          <a:prstGeom prst="rect">
+            <a:avLst/>
+          </a:prstGeom>
+          <a:noFill/>
+          <a:ln/>
+        </p:spPr>
+        <p:txBody>
+          <a:bodyPr wrap="square" lIns="0" tIns="0" rIns="0" bIns="0" rtlCol="0" anchor="b"/>
+          <a:lstStyle/>
+          <a:p>
+            <a:pPr indent="0" marL="0">
+              <a:buNone/>
+            </a:pPr>
+            <a:r>
+              <a:rPr lang="en-US" sz="4000" b="1" dirty="0">
+                <a:solidFill>
+                  <a:schemeClr val="accent2"/>
+                </a:solidFill>
+                <a:latin typeface="Cambria" pitchFamily="34" charset="0"/>
+                <a:ea typeface="Cambria" pitchFamily="34" charset="-122"/>
+                <a:cs typeface="Cambria" pitchFamily="34" charset="-120"/>
+              </a:rPr>
+              <a:t>35%</a:t>
+            </a:r>
+            <a:endParaRPr lang="en-US" sz="4000" dirty="0"/>
+          </a:p>
+        </p:txBody>
+      </p:sp>
+      <p:sp>
+        <p:nvSpPr>
+          <p:cNvPr id="19" name="Text 17"/>
+          <p:cNvSpPr txBox="1"/>
+          <p:nvPr/>
+        </p:nvSpPr>
+        <p:spPr>
+          <a:xfrm>
+            <a:off x="822960" y="5120640"/>
+            <a:ext cx="2148840" cy="822960"/>
           </a:xfrm>
           <a:prstGeom prst="rect">
             <a:avLst/>
@@ -12680,25 +12809,305 @@
               <a:buNone/>
             </a:pPr>
             <a:r>
-              <a:rPr lang="en-US" sz="1500" b="1" dirty="0">
+              <a:rPr lang="en-US" sz="1400" dirty="0">
                 <a:solidFill>
                   <a:schemeClr val="tx1"/>
                 </a:solidFill>
               </a:rPr>
-              <a:t>Why a policy matters: </a:t>
-            </a:r>
+              <a:t>of real lows warned at least 30 min ahead (53% at 15 min)</a:t>
+            </a:r>
+            <a:endParaRPr lang="en-US" sz="1400" dirty="0"/>
+          </a:p>
+        </p:txBody>
+      </p:sp>
+      <p:sp>
+        <p:nvSpPr>
+          <p:cNvPr id="20" name="card"/>
+          <p:cNvSpPr/>
+          <p:nvPr/>
+        </p:nvSpPr>
+        <p:spPr>
+          <a:xfrm>
+            <a:off x="3364992" y="4160520"/>
+            <a:ext cx="2606040" cy="1874520"/>
+          </a:xfrm>
+          <a:prstGeom prst="roundRect">
+            <a:avLst>
+              <a:gd name="adj" fmla="val 5854"/>
+            </a:avLst>
+          </a:prstGeom>
+          <a:solidFill>
+            <a:schemeClr val="bg2"/>
+          </a:solidFill>
+          <a:ln/>
+        </p:spPr>
+      </p:sp>
+      <p:sp>
+        <p:nvSpPr>
+          <p:cNvPr id="21" name="Text 19"/>
+          <p:cNvSpPr txBox="1"/>
+          <p:nvPr/>
+        </p:nvSpPr>
+        <p:spPr>
+          <a:xfrm>
+            <a:off x="3639312" y="4251960"/>
+            <a:ext cx="2148840" cy="777240"/>
+          </a:xfrm>
+          <a:prstGeom prst="rect">
+            <a:avLst/>
+          </a:prstGeom>
+          <a:noFill/>
+          <a:ln/>
+        </p:spPr>
+        <p:txBody>
+          <a:bodyPr wrap="square" lIns="0" tIns="0" rIns="0" bIns="0" rtlCol="0" anchor="b"/>
+          <a:lstStyle/>
+          <a:p>
             <a:pPr indent="0" marL="0">
               <a:buNone/>
             </a:pPr>
             <a:r>
-              <a:rPr lang="en-US" sz="1500" dirty="0">
+              <a:rPr lang="en-US" sz="4000" b="1" dirty="0">
+                <a:solidFill>
+                  <a:schemeClr val="accent2"/>
+                </a:solidFill>
+                <a:latin typeface="Cambria" pitchFamily="34" charset="0"/>
+                <a:ea typeface="Cambria" pitchFamily="34" charset="-122"/>
+                <a:cs typeface="Cambria" pitchFamily="34" charset="-120"/>
+              </a:rPr>
+              <a:t>25 min</a:t>
+            </a:r>
+            <a:endParaRPr lang="en-US" sz="4000" dirty="0"/>
+          </a:p>
+        </p:txBody>
+      </p:sp>
+      <p:sp>
+        <p:nvSpPr>
+          <p:cNvPr id="22" name="Text 20"/>
+          <p:cNvSpPr txBox="1"/>
+          <p:nvPr/>
+        </p:nvSpPr>
+        <p:spPr>
+          <a:xfrm>
+            <a:off x="3639312" y="5120640"/>
+            <a:ext cx="2148840" cy="822960"/>
+          </a:xfrm>
+          <a:prstGeom prst="rect">
+            <a:avLst/>
+          </a:prstGeom>
+          <a:noFill/>
+          <a:ln/>
+        </p:spPr>
+        <p:txBody>
+          <a:bodyPr wrap="square" lIns="0" tIns="0" rIns="0" bIns="0" rtlCol="0" anchor="t"/>
+          <a:lstStyle/>
+          <a:p>
+            <a:pPr indent="0" marL="0">
+              <a:buNone/>
+            </a:pPr>
+            <a:r>
+              <a:rPr lang="en-US" sz="1400" dirty="0">
                 <a:solidFill>
                   <a:schemeClr val="tx1"/>
                 </a:solidFill>
               </a:rPr>
-              <a:t>raising an alert every time the risk is high would mean about 3 alerting windows per patient-day with only 18% true. Our policy alerts once per risk episode, never while the CGM already reads low, and was tuned on validation patients only. It trades a little sensitivity (98% to 76% caught 30 min ahead) for 6x fewer alerts.</a:t>
-            </a:r>
-            <a:endParaRPr lang="en-US" sz="1500" dirty="0"/>
+              <a:t>median warning</a:t>
+            </a:r>
+            <a:endParaRPr lang="en-US" sz="1400" dirty="0"/>
+          </a:p>
+        </p:txBody>
+      </p:sp>
+      <p:sp>
+        <p:nvSpPr>
+          <p:cNvPr id="23" name="card"/>
+          <p:cNvSpPr/>
+          <p:nvPr/>
+        </p:nvSpPr>
+        <p:spPr>
+          <a:xfrm>
+            <a:off x="6181344" y="4160520"/>
+            <a:ext cx="2606040" cy="1874520"/>
+          </a:xfrm>
+          <a:prstGeom prst="roundRect">
+            <a:avLst>
+              <a:gd name="adj" fmla="val 5854"/>
+            </a:avLst>
+          </a:prstGeom>
+          <a:solidFill>
+            <a:schemeClr val="bg2"/>
+          </a:solidFill>
+          <a:ln/>
+        </p:spPr>
+      </p:sp>
+      <p:sp>
+        <p:nvSpPr>
+          <p:cNvPr id="24" name="Text 22"/>
+          <p:cNvSpPr txBox="1"/>
+          <p:nvPr/>
+        </p:nvSpPr>
+        <p:spPr>
+          <a:xfrm>
+            <a:off x="6455664" y="4251960"/>
+            <a:ext cx="2148840" cy="777240"/>
+          </a:xfrm>
+          <a:prstGeom prst="rect">
+            <a:avLst/>
+          </a:prstGeom>
+          <a:noFill/>
+          <a:ln/>
+        </p:spPr>
+        <p:txBody>
+          <a:bodyPr wrap="square" lIns="0" tIns="0" rIns="0" bIns="0" rtlCol="0" anchor="b"/>
+          <a:lstStyle/>
+          <a:p>
+            <a:pPr indent="0" marL="0">
+              <a:buNone/>
+            </a:pPr>
+            <a:r>
+              <a:rPr lang="en-US" sz="4000" b="1" dirty="0">
+                <a:solidFill>
+                  <a:schemeClr val="accent2"/>
+                </a:solidFill>
+                <a:latin typeface="Cambria" pitchFamily="34" charset="0"/>
+                <a:ea typeface="Cambria" pitchFamily="34" charset="-122"/>
+                <a:cs typeface="Cambria" pitchFamily="34" charset="-120"/>
+              </a:rPr>
+              <a:t>0.61</a:t>
+            </a:r>
+            <a:endParaRPr lang="en-US" sz="4000" dirty="0"/>
+          </a:p>
+        </p:txBody>
+      </p:sp>
+      <p:sp>
+        <p:nvSpPr>
+          <p:cNvPr id="25" name="Text 23"/>
+          <p:cNvSpPr txBox="1"/>
+          <p:nvPr/>
+        </p:nvSpPr>
+        <p:spPr>
+          <a:xfrm>
+            <a:off x="6455664" y="5120640"/>
+            <a:ext cx="2148840" cy="822960"/>
+          </a:xfrm>
+          <a:prstGeom prst="rect">
+            <a:avLst/>
+          </a:prstGeom>
+          <a:noFill/>
+          <a:ln/>
+        </p:spPr>
+        <p:txBody>
+          <a:bodyPr wrap="square" lIns="0" tIns="0" rIns="0" bIns="0" rtlCol="0" anchor="t"/>
+          <a:lstStyle/>
+          <a:p>
+            <a:pPr indent="0" marL="0">
+              <a:buNone/>
+            </a:pPr>
+            <a:r>
+              <a:rPr lang="en-US" sz="1400" dirty="0">
+                <a:solidFill>
+                  <a:schemeClr val="tx1"/>
+                </a:solidFill>
+              </a:rPr>
+              <a:t>alerts per patient-day</a:t>
+            </a:r>
+            <a:endParaRPr lang="en-US" sz="1400" dirty="0"/>
+          </a:p>
+        </p:txBody>
+      </p:sp>
+      <p:sp>
+        <p:nvSpPr>
+          <p:cNvPr id="26" name="card"/>
+          <p:cNvSpPr/>
+          <p:nvPr/>
+        </p:nvSpPr>
+        <p:spPr>
+          <a:xfrm>
+            <a:off x="8997696" y="4160520"/>
+            <a:ext cx="2606040" cy="1874520"/>
+          </a:xfrm>
+          <a:prstGeom prst="roundRect">
+            <a:avLst>
+              <a:gd name="adj" fmla="val 5854"/>
+            </a:avLst>
+          </a:prstGeom>
+          <a:solidFill>
+            <a:schemeClr val="bg2"/>
+          </a:solidFill>
+          <a:ln/>
+        </p:spPr>
+      </p:sp>
+      <p:sp>
+        <p:nvSpPr>
+          <p:cNvPr id="27" name="Text 25"/>
+          <p:cNvSpPr txBox="1"/>
+          <p:nvPr/>
+        </p:nvSpPr>
+        <p:spPr>
+          <a:xfrm>
+            <a:off x="9272016" y="4251960"/>
+            <a:ext cx="2148840" cy="777240"/>
+          </a:xfrm>
+          <a:prstGeom prst="rect">
+            <a:avLst/>
+          </a:prstGeom>
+          <a:noFill/>
+          <a:ln/>
+        </p:spPr>
+        <p:txBody>
+          <a:bodyPr wrap="square" lIns="0" tIns="0" rIns="0" bIns="0" rtlCol="0" anchor="b"/>
+          <a:lstStyle/>
+          <a:p>
+            <a:pPr indent="0" marL="0">
+              <a:buNone/>
+            </a:pPr>
+            <a:r>
+              <a:rPr lang="en-US" sz="4000" b="1" dirty="0">
+                <a:solidFill>
+                  <a:schemeClr val="accent2"/>
+                </a:solidFill>
+                <a:latin typeface="Cambria" pitchFamily="34" charset="0"/>
+                <a:ea typeface="Cambria" pitchFamily="34" charset="-122"/>
+                <a:cs typeface="Cambria" pitchFamily="34" charset="-120"/>
+              </a:rPr>
+              <a:t>44%</a:t>
+            </a:r>
+            <a:endParaRPr lang="en-US" sz="4000" dirty="0"/>
+          </a:p>
+        </p:txBody>
+      </p:sp>
+      <p:sp>
+        <p:nvSpPr>
+          <p:cNvPr id="28" name="Text 26"/>
+          <p:cNvSpPr txBox="1"/>
+          <p:nvPr/>
+        </p:nvSpPr>
+        <p:spPr>
+          <a:xfrm>
+            <a:off x="9272016" y="5120640"/>
+            <a:ext cx="2148840" cy="822960"/>
+          </a:xfrm>
+          <a:prstGeom prst="rect">
+            <a:avLst/>
+          </a:prstGeom>
+          <a:noFill/>
+          <a:ln/>
+        </p:spPr>
+        <p:txBody>
+          <a:bodyPr wrap="square" lIns="0" tIns="0" rIns="0" bIns="0" rtlCol="0" anchor="t"/>
+          <a:lstStyle/>
+          <a:p>
+            <a:pPr indent="0" marL="0">
+              <a:buNone/>
+            </a:pPr>
+            <a:r>
+              <a:rPr lang="en-US" sz="1400" dirty="0">
+                <a:solidFill>
+                  <a:schemeClr val="tx1"/>
+                </a:solidFill>
+              </a:rPr>
+              <a:t>of alerts followed by a real low</a:t>
+            </a:r>
+            <a:endParaRPr lang="en-US" sz="1400" dirty="0"/>
           </a:p>
         </p:txBody>
       </p:sp>

</xml_diff>